<commit_message>
[2510631109] record independent human pair UAT (TYX, 2026-07-29)
新增 process/uat/launchspec-ai-human-pair-uat-2026-07-29.md：
- 测试者 TYX（未参与开发），Edge，demo provider
- U-03 生成蓝图首次不可用、内容不显示，处理后复测通过
- 其余 6 项一次通过；U-04~U-07 在 U-03 修复后重新执行
- 测试者未表述的两项反馈如实留空，未代写

如实说明：本次处理未产生业务代码提交（6b2fe9c 与 5a3b56d
之间无提交，工作区干净），记录中不引用修复提交号。

同步更新 Gate 3（F-1 转为已完成）、PROCESS、evidence 索引、
draft-uat、第 2 次周志、最终报告与 12 页答辩 PPT。
7-23 本人 UAT 记录保持原文，仅追加后续补记。
</commit_message>
<xml_diff>
--- a/projects/launchspec-ai/submissions/2510631109-launchspec-ai-defense.pptx
+++ b/projects/launchspec-ai/submissions/2510631109-launchspec-ai-defense.pptx
@@ -583,7 +583,7 @@
           <a:lstStyle/>
           <a:p>
             <a:r>
-              <a:t>主动交代缺口，不等评委问。特别是提交粒度问题——要讲清楚为什么不补：补了就是伪造。这个态度本身就是课程要考的工程诚实。</a:t>
+              <a:t>主动交代缺口，不等评委问。特别是提交粒度问题——要讲清楚为什么不补：补了就是伪造。这个态度本身就是课程要考的工程诚实。真人 UAT 已补齐，可正面说明。</a:t>
             </a:r>
           </a:p>
         </p:txBody>
@@ -1143,7 +1143,7 @@
           <a:lstStyle/>
           <a:p>
             <a:r>
-              <a:t>回答『哪个测试最能证明系统质量』：不是单元测试，是人工 UAT。因为它抓到了其他所有层都抓不到的问题。这是本项目最有说服力的一条经验。</a:t>
+              <a:t>回答『哪个测试最能证明系统质量』：不是单元测试，是人工 UAT。两次真人验收各抓到一个自动化看不见的问题——7-23 本人发现白屏与 hydration 失败，7-29 测试者 TYX 发现生成蓝图不可用。这是本项目最有说服力的经验。</a:t>
             </a:r>
           </a:p>
         </p:txBody>
@@ -4904,7 +4904,7 @@
                           </a:solidFill>
                           <a:latin typeface="Helvetica Neue"/>
                         </a:rPr>
-                        <a:t>独立真人结对 UAT 未完成；提交粒度缺口</a:t>
+                        <a:t>提交粒度缺口（真人 UAT 已于 07-29 补齐）</a:t>
                       </a:r>
                     </a:p>
                   </a:txBody>
@@ -4949,7 +4949,7 @@
                 </a:solidFill>
                 <a:latin typeface="Helvetica Neue"/>
               </a:rPr>
-              <a:t>两个确认存在的缺口</a:t>
+              <a:t>确认存在的缺口</a:t>
             </a:r>
           </a:p>
           <a:p>
@@ -4965,7 +4965,7 @@
                 </a:solidFill>
                 <a:latin typeface="Helvetica Neue"/>
               </a:rPr>
-              <a:t>① 提交 4414ea4 一次性引入 79 文件、11407 行，覆盖 C1–C7 全部任务卡，无法逐卡对应，也无法体现红绿顺序。</a:t>
+              <a:t>提交 4414ea4 一次性引入 79 文件、11407 行，覆盖 C1–C7 全部任务卡，无法逐卡对应，也无法体现红绿顺序。</a:t>
             </a:r>
           </a:p>
           <a:p>
@@ -4981,7 +4981,7 @@
                 </a:solidFill>
                 <a:latin typeface="Helvetica Neue"/>
               </a:rPr>
-              <a:t>② 独立真人结对 UAT 仍是空模板；现有三类 UAT 分别是自动化 CLI、自动化浏览器、项目本人验收，都不构成未参与开发者的独立反馈。</a:t>
+              <a:t>已补齐：独立真人结对 UAT 于 2026-07-29 由未参与开发的测试者 TYX 完成，发现并复测了 1 项阻断问题。</a:t>
             </a:r>
           </a:p>
           <a:p>
@@ -4997,7 +4997,7 @@
                 </a:solidFill>
                 <a:latin typeface="Helvetica Neue"/>
               </a:rPr>
-              <a:t>缺口①不做补救——补写『先失败的提交』等同伪造历史，属课程红线。处理方式是如实声明，并以集中期 arena-lite 的红绿证据说明方法已掌握。</a:t>
+              <a:t>提交粒度缺口不做补救——补写『先失败的提交』等同伪造历史，属课程红线。处理方式是如实声明，并以集中期 arena-lite 的红绿证据说明方法已掌握。</a:t>
             </a:r>
           </a:p>
         </p:txBody>
@@ -5267,22 +5267,6 @@
           <a:p>
             <a:pPr algn="l">
               <a:spcAft>
-                <a:spcPts val="900"/>
-              </a:spcAft>
-            </a:pPr>
-            <a:r>
-              <a:rPr sz="1400" b="0">
-                <a:solidFill>
-                  <a:srgbClr val="1A1A1A"/>
-                </a:solidFill>
-                <a:latin typeface="Helvetica Neue"/>
-              </a:rPr>
-              <a:t>5　未完成独立真人结对 UAT。</a:t>
-            </a:r>
-          </a:p>
-          <a:p>
-            <a:pPr algn="l">
-              <a:spcAft>
                 <a:spcPts val="800"/>
               </a:spcAft>
             </a:pPr>
@@ -5293,7 +5277,7 @@
                 </a:solidFill>
                 <a:latin typeface="Helvetica Neue"/>
               </a:rPr>
-              <a:t>6　未保留测试先行的红绿提交序列。</a:t>
+              <a:t>5　未保留测试先行的红绿提交序列。</a:t>
             </a:r>
           </a:p>
         </p:txBody>
@@ -5396,7 +5380,7 @@
                 </a:solidFill>
                 <a:latin typeface="Helvetica Neue"/>
               </a:rPr>
-              <a:t>补　独立真人结对 UAT 与评审人复述。</a:t>
+              <a:t>补　独立评审人对 PRD/SPEC 的复述记录。</a:t>
             </a:r>
           </a:p>
           <a:p>
@@ -5816,7 +5800,7 @@
                           </a:solidFill>
                           <a:latin typeface="Helvetica Neue"/>
                         </a:rPr>
-                        <a:t>人工 UAT，抓到自动化看不到的白屏与 hydration 故障</a:t>
+                        <a:t>两次真人验收各抓到一个自动化看不见的问题</a:t>
                       </a:r>
                     </a:p>
                   </a:txBody>
@@ -5834,7 +5818,7 @@
                           </a:solidFill>
                           <a:latin typeface="Helvetica Neue"/>
                         </a:rPr>
-                        <a:t>human-uat-2026-07-23.md</a:t>
+                        <a:t>human-pair-uat-2026-07-29.md</a:t>
                       </a:r>
                     </a:p>
                   </a:txBody>
@@ -6040,7 +6024,7 @@
                           </a:solidFill>
                           <a:latin typeface="Helvetica Neue"/>
                         </a:rPr>
-                        <a:t>单机、无并发、demo 非真实证据、两项证据缺口</a:t>
+                        <a:t>单机、无并发、demo 非真实证据、红绿序列缺口</a:t>
                       </a:r>
                     </a:p>
                   </a:txBody>
@@ -8761,7 +8745,7 @@
         </p:nvGraphicFramePr>
         <p:xfrm>
           <a:off x="868680" y="2194560"/>
-          <a:ext cx="10424160" cy="2651760"/>
+          <a:ext cx="10424160" cy="2834640"/>
         </p:xfrm>
         <a:graphic>
           <a:graphicData uri="http://schemas.openxmlformats.org/drawingml/2006/table">
@@ -8774,7 +8758,7 @@
                 <a:gridCol w="5120640"/>
                 <a:gridCol w="2286000"/>
               </a:tblGrid>
-              <a:tr h="441960">
+              <a:tr h="404948">
                 <a:tc>
                   <a:txBody>
                     <a:bodyPr/>
@@ -8830,7 +8814,7 @@
                   <a:tcPr marL="91440" marR="91440" marT="41148" marB="41148"/>
                 </a:tc>
               </a:tr>
-              <a:tr h="441960">
+              <a:tr h="404948">
                 <a:tc>
                   <a:txBody>
                     <a:bodyPr/>
@@ -8886,7 +8870,7 @@
                   <a:tcPr marL="91440" marR="91440" marT="41148" marB="41148"/>
                 </a:tc>
               </a:tr>
-              <a:tr h="441960">
+              <a:tr h="404948">
                 <a:tc>
                   <a:txBody>
                     <a:bodyPr/>
@@ -8942,7 +8926,7 @@
                   <a:tcPr marL="91440" marR="91440" marT="41148" marB="41148"/>
                 </a:tc>
               </a:tr>
-              <a:tr h="441960">
+              <a:tr h="404948">
                 <a:tc>
                   <a:txBody>
                     <a:bodyPr/>
@@ -8998,7 +8982,7 @@
                   <a:tcPr marL="91440" marR="91440" marT="41148" marB="41148"/>
                 </a:tc>
               </a:tr>
-              <a:tr h="441960">
+              <a:tr h="404948">
                 <a:tc>
                   <a:txBody>
                     <a:bodyPr/>
@@ -9054,7 +9038,7 @@
                   <a:tcPr marL="91440" marR="91440" marT="41148" marB="41148"/>
                 </a:tc>
               </a:tr>
-              <a:tr h="441960">
+              <a:tr h="404948">
                 <a:tc>
                   <a:txBody>
                     <a:bodyPr/>
@@ -9103,7 +9087,63 @@
                           </a:solidFill>
                           <a:latin typeface="Helvetica Neue"/>
                         </a:rPr>
-                        <a:t>PASS WITH EVIDENCE LIMITS</a:t>
+                        <a:t>PASS WITH LIMITS</a:t>
+                      </a:r>
+                    </a:p>
+                  </a:txBody>
+                  <a:tcPr marL="91440" marR="91440" marT="41148" marB="41148"/>
+                </a:tc>
+              </a:tr>
+              <a:tr h="404952">
+                <a:tc>
+                  <a:txBody>
+                    <a:bodyPr/>
+                    <a:lstStyle/>
+                    <a:p>
+                      <a:r>
+                        <a:rPr sz="1300" b="0">
+                          <a:solidFill>
+                            <a:srgbClr val="1A1A1A"/>
+                          </a:solidFill>
+                          <a:latin typeface="Helvetica Neue"/>
+                        </a:rPr>
+                        <a:t>独立真人结对 UAT</a:t>
+                      </a:r>
+                    </a:p>
+                  </a:txBody>
+                  <a:tcPr marL="91440" marR="91440" marT="41148" marB="41148"/>
+                </a:tc>
+                <a:tc>
+                  <a:txBody>
+                    <a:bodyPr/>
+                    <a:lstStyle/>
+                    <a:p>
+                      <a:r>
+                        <a:rPr sz="1300" b="0">
+                          <a:solidFill>
+                            <a:srgbClr val="1A1A1A"/>
+                          </a:solidFill>
+                          <a:latin typeface="Helvetica Neue"/>
+                        </a:rPr>
+                        <a:t>测试者 TYX（未参与开发）· Edge · 7 个场景</a:t>
+                      </a:r>
+                    </a:p>
+                  </a:txBody>
+                  <a:tcPr marL="91440" marR="91440" marT="41148" marB="41148"/>
+                </a:tc>
+                <a:tc>
+                  <a:txBody>
+                    <a:bodyPr/>
+                    <a:lstStyle/>
+                    <a:p>
+                      <a:r>
+                        <a:rPr sz="1300" b="0">
+                          <a:solidFill>
+                            <a:srgbClr val="1A1A1A"/>
+                          </a:solidFill>
+                          <a:latin typeface="Helvetica Neue"/>
+                        </a:rPr>
+                        <a:t>通过（U-03 复测）</a:t>
                       </a:r>
                     </a:p>
                   </a:txBody>
@@ -9122,7 +9162,7 @@
         </p:nvSpPr>
         <p:spPr>
           <a:xfrm>
-            <a:off x="868680" y="5349240"/>
+            <a:off x="868680" y="5440680"/>
             <a:ext cx="10424160" cy="1280160"/>
           </a:xfrm>
           <a:prstGeom prst="rect">
@@ -9148,7 +9188,7 @@
                 </a:solidFill>
                 <a:latin typeface="Helvetica Neue"/>
               </a:rPr>
-              <a:t>最能证明质量的一项：人工 UAT 发现了自动化完全没发现的两个阻塞问题。</a:t>
+              <a:t>最能证明质量的一项：两次真人验收都抓到了自动化完全没发现的问题。</a:t>
             </a:r>
           </a:p>
           <a:p>
@@ -9164,7 +9204,7 @@
                 </a:solidFill>
                 <a:latin typeface="Helvetica Neue"/>
               </a:rPr>
-              <a:t>13 个测试全绿、API 全部 200 的情况下，浏览器打开却是白屏——这正是下一页要讲的决策推翻。</a:t>
+              <a:t>13 个测试全绿、API 全部 200 的情况下，浏览器打开却是白屏；真人测试者 TYX 又发现生成蓝图首次不可用。</a:t>
             </a:r>
           </a:p>
         </p:txBody>

</xml_diff>

<commit_message>
[2510631109] record tester restatement and PRD positioning finding
TYX（未参与开发）使用后复述：「提出想法然后由 AI 进行总结最后
给出项目的方案」。记录于真人结对 UAT 第 7 节。

判定：不计入 Gate 1 通过。手册要求的是读完 PRD/SPEC 后的复述，
本条是使用产品后的复述，验证对象不同，不可互相替代。文档阅读式
复述仍为 Gate 1 未满足项。

发现的真实缺陷：复述把 AI 动作理解为「总结」（实为从一句话展开
成 8 个板块），且完全未提及人工编辑与审查环节。说明「AI 给草案，
人做决策」的核心立场在产品交互与文档表述中均传达不足。已列为
PRD 第 1 节改进动作。

同步 Gate 1、gate/README、第 1 次周志、最终报告与答辩 PPT。
</commit_message>
<xml_diff>
--- a/projects/launchspec-ai/submissions/2510631109-launchspec-ai-defense.pptx
+++ b/projects/launchspec-ai/submissions/2510631109-launchspec-ai-defense.pptx
@@ -4792,7 +4792,7 @@
                           </a:solidFill>
                           <a:latin typeface="Helvetica Neue"/>
                         </a:rPr>
-                        <a:t>独立真人评审人复述未完成</a:t>
+                        <a:t>文档阅读式复述未完成（已有使用后复述）</a:t>
                       </a:r>
                     </a:p>
                   </a:txBody>
@@ -4971,6 +4971,22 @@
           <a:p>
             <a:pPr algn="l">
               <a:spcAft>
+                <a:spcPts val="800"/>
+              </a:spcAft>
+            </a:pPr>
+            <a:r>
+              <a:rPr sz="1400" b="0">
+                <a:solidFill>
+                  <a:srgbClr val="1A1A1A"/>
+                </a:solidFill>
+                <a:latin typeface="Helvetica Neue"/>
+              </a:rPr>
+              <a:t>已补齐：独立真人结对 UAT 于 2026-07-29 由未参与开发的测试者 TYX 完成，发现并复测了 1 项阻断问题。</a:t>
+            </a:r>
+          </a:p>
+          <a:p>
+            <a:pPr algn="l">
+              <a:spcAft>
                 <a:spcPts val="1200"/>
               </a:spcAft>
             </a:pPr>
@@ -4981,7 +4997,7 @@
                 </a:solidFill>
                 <a:latin typeface="Helvetica Neue"/>
               </a:rPr>
-              <a:t>已补齐：独立真人结对 UAT 于 2026-07-29 由未参与开发的测试者 TYX 完成，发现并复测了 1 项阻断问题。</a:t>
+              <a:t>同一测试者用完后把系统复述为「AI 总结出方案」，未提到人工编辑与审查——说明「AI 给草案，人做决策」这一核心立场传达不足，已列入 PRD 改进动作。</a:t>
             </a:r>
           </a:p>
           <a:p>

</xml_diff>

<commit_message>
[2510631109] fill final frozen commit id in submission deliverables
把最终报告第 1 节与第 2 次周志第 8 节的「见收官提交的 git log」占位
表述替换为真实 SHA ab364f051ff81925fa9964539a6663d7bf0390ab，答辩 PPT
封面与 Q&A 备份页同步同一短号。

冻结口径：代码、测试、证据与全部评审结论冻结于 ab364f0；本提交只补录
提交号字段本身，不改动代码、测试、证据或结论。自引用 SHA 无法预先写入，
故以内容冻结点为准并在报告中写明该口径。

验证：npm run check 通过（13 tests / 6 files、build、lint）；
scripts/check.sh 通过（22 passed、git diff --check 空）；
PPT 复查 12 页、越界形状 0、Q&A 表底 6.40in（画布 7.50in）。

Co-Authored-By: Claude Opus 5 (1M context) <noreply@anthropic.com>
</commit_message>
<xml_diff>
--- a/projects/launchspec-ai/submissions/2510631109-launchspec-ai-defense.pptx
+++ b/projects/launchspec-ai/submissions/2510631109-launchspec-ai-defense.pptx
@@ -513,7 +513,7 @@
           <a:lstStyle/>
           <a:p>
             <a:r>
-              <a:t>自我介绍与项目一句话定位。强调这是提交期自选项目，与集中期跟练的 arena-lite 在用户、场景、接口和技术栈上完全不同。控制在 30 秒内进入正题。</a:t>
+              <a:t>自我介绍与项目一句话定位。强调这是提交期自选项目，与集中期跟练的 arena-lite 在用户、场景、接口和技术栈上完全不同。控制在 30 秒内进入正题。若被问最终版本，冻结提交号 ab364f0 已写在封面，详见最终报告第 1 节。</a:t>
             </a:r>
           </a:p>
         </p:txBody>
@@ -4488,17 +4488,33 @@
           <a:p>
             <a:pPr algn="l">
               <a:spcAft>
+                <a:spcPts val="400"/>
+              </a:spcAft>
+            </a:pPr>
+            <a:r>
+              <a:rPr sz="1300" b="0">
+                <a:solidFill>
+                  <a:srgbClr val="6B6B6B"/>
+                </a:solidFill>
+                <a:latin typeface="Helvetica Neue"/>
+              </a:rPr>
+              <a:t>Next.js 16 · TypeScript · 本地 JSON 存储　|　2026-08-02</a:t>
+            </a:r>
+          </a:p>
+          <a:p>
+            <a:pPr algn="l">
+              <a:spcAft>
                 <a:spcPts val="800"/>
               </a:spcAft>
             </a:pPr>
             <a:r>
-              <a:rPr sz="1300" b="0">
+              <a:rPr sz="1200" b="0">
                 <a:solidFill>
                   <a:srgbClr val="6B6B6B"/>
                 </a:solidFill>
                 <a:latin typeface="Helvetica Neue"/>
               </a:rPr>
-              <a:t>Next.js 16 · TypeScript · 本地 JSON 存储　|　2026-08-02</a:t>
+              <a:t>最终冻结提交　ab364f0　|　分支 feat/2510631109-local-ci</a:t>
             </a:r>
           </a:p>
         </p:txBody>
@@ -5617,7 +5633,7 @@
                 <a:gridCol w="4846320"/>
                 <a:gridCol w="2377440"/>
               </a:tblGrid>
-              <a:tr h="457200">
+              <a:tr h="406400">
                 <a:tc>
                   <a:txBody>
                     <a:bodyPr/>
@@ -5673,7 +5689,7 @@
                   <a:tcPr marL="91440" marR="91440" marT="41148" marB="41148"/>
                 </a:tc>
               </a:tr>
-              <a:tr h="457200">
+              <a:tr h="406400">
                 <a:tc>
                   <a:txBody>
                     <a:bodyPr/>
@@ -5729,7 +5745,7 @@
                   <a:tcPr marL="91440" marR="91440" marT="41148" marB="41148"/>
                 </a:tc>
               </a:tr>
-              <a:tr h="457200">
+              <a:tr h="406400">
                 <a:tc>
                   <a:txBody>
                     <a:bodyPr/>
@@ -5785,7 +5801,7 @@
                   <a:tcPr marL="91440" marR="91440" marT="41148" marB="41148"/>
                 </a:tc>
               </a:tr>
-              <a:tr h="457200">
+              <a:tr h="406400">
                 <a:tc>
                   <a:txBody>
                     <a:bodyPr/>
@@ -5841,7 +5857,7 @@
                   <a:tcPr marL="91440" marR="91440" marT="41148" marB="41148"/>
                 </a:tc>
               </a:tr>
-              <a:tr h="457200">
+              <a:tr h="406400">
                 <a:tc>
                   <a:txBody>
                     <a:bodyPr/>
@@ -5897,7 +5913,7 @@
                   <a:tcPr marL="91440" marR="91440" marT="41148" marB="41148"/>
                 </a:tc>
               </a:tr>
-              <a:tr h="457200">
+              <a:tr h="406400">
                 <a:tc>
                   <a:txBody>
                     <a:bodyPr/>
@@ -5953,7 +5969,7 @@
                   <a:tcPr marL="91440" marR="91440" marT="41148" marB="41148"/>
                 </a:tc>
               </a:tr>
-              <a:tr h="457200">
+              <a:tr h="406400">
                 <a:tc>
                   <a:txBody>
                     <a:bodyPr/>
@@ -6009,7 +6025,7 @@
                   <a:tcPr marL="91440" marR="91440" marT="41148" marB="41148"/>
                 </a:tc>
               </a:tr>
-              <a:tr h="457200">
+              <a:tr h="406400">
                 <a:tc>
                   <a:txBody>
                     <a:bodyPr/>
@@ -6059,6 +6075,62 @@
                           <a:latin typeface="Helvetica Neue"/>
                         </a:rPr>
                         <a:t>final-report.md §12</a:t>
+                      </a:r>
+                    </a:p>
+                  </a:txBody>
+                  <a:tcPr marL="91440" marR="91440" marT="41148" marB="41148"/>
+                </a:tc>
+              </a:tr>
+              <a:tr h="406400">
+                <a:tc>
+                  <a:txBody>
+                    <a:bodyPr/>
+                    <a:lstStyle/>
+                    <a:p>
+                      <a:r>
+                        <a:rPr sz="1200" b="0">
+                          <a:solidFill>
+                            <a:srgbClr val="1A1A1A"/>
+                          </a:solidFill>
+                          <a:latin typeface="Helvetica Neue"/>
+                        </a:rPr>
+                        <a:t>最终版本冻结在哪个提交？</a:t>
+                      </a:r>
+                    </a:p>
+                  </a:txBody>
+                  <a:tcPr marL="91440" marR="91440" marT="41148" marB="41148"/>
+                </a:tc>
+                <a:tc>
+                  <a:txBody>
+                    <a:bodyPr/>
+                    <a:lstStyle/>
+                    <a:p>
+                      <a:r>
+                        <a:rPr sz="1200" b="0">
+                          <a:solidFill>
+                            <a:srgbClr val="1A1A1A"/>
+                          </a:solidFill>
+                          <a:latin typeface="Helvetica Neue"/>
+                        </a:rPr>
+                        <a:t>ab364f0（2026-08-02），之后无内容变更</a:t>
+                      </a:r>
+                    </a:p>
+                  </a:txBody>
+                  <a:tcPr marL="91440" marR="91440" marT="41148" marB="41148"/>
+                </a:tc>
+                <a:tc>
+                  <a:txBody>
+                    <a:bodyPr/>
+                    <a:lstStyle/>
+                    <a:p>
+                      <a:r>
+                        <a:rPr sz="1200" b="0">
+                          <a:solidFill>
+                            <a:srgbClr val="1A1A1A"/>
+                          </a:solidFill>
+                          <a:latin typeface="Helvetica Neue"/>
+                        </a:rPr>
+                        <a:t>final-report.md §1</a:t>
                       </a:r>
                     </a:p>
                   </a:txBody>

</xml_diff>